<commit_message>
Deployed e46c0a3d with MkDocs version: 1.2.3
</commit_message>
<xml_diff>
--- a/Style/Icon Graphics.pptx
+++ b/Style/Icon Graphics.pptx
@@ -261,7 +261,7 @@
           <a:p>
             <a:fld id="{1FA95016-962F-486B-9A5C-BEFA49183FF1}" type="datetimeFigureOut">
               <a:rPr lang="sv-FI" smtClean="0"/>
-              <a:t>13-05-2022</a:t>
+              <a:t>2024-01-26</a:t>
             </a:fld>
             <a:endParaRPr lang="sv-FI"/>
           </a:p>
@@ -461,7 +461,7 @@
           <a:p>
             <a:fld id="{1FA95016-962F-486B-9A5C-BEFA49183FF1}" type="datetimeFigureOut">
               <a:rPr lang="sv-FI" smtClean="0"/>
-              <a:t>13-05-2022</a:t>
+              <a:t>2024-01-26</a:t>
             </a:fld>
             <a:endParaRPr lang="sv-FI"/>
           </a:p>
@@ -671,7 +671,7 @@
           <a:p>
             <a:fld id="{1FA95016-962F-486B-9A5C-BEFA49183FF1}" type="datetimeFigureOut">
               <a:rPr lang="sv-FI" smtClean="0"/>
-              <a:t>13-05-2022</a:t>
+              <a:t>2024-01-26</a:t>
             </a:fld>
             <a:endParaRPr lang="sv-FI"/>
           </a:p>
@@ -871,7 +871,7 @@
           <a:p>
             <a:fld id="{1FA95016-962F-486B-9A5C-BEFA49183FF1}" type="datetimeFigureOut">
               <a:rPr lang="sv-FI" smtClean="0"/>
-              <a:t>13-05-2022</a:t>
+              <a:t>2024-01-26</a:t>
             </a:fld>
             <a:endParaRPr lang="sv-FI"/>
           </a:p>
@@ -1147,7 +1147,7 @@
           <a:p>
             <a:fld id="{1FA95016-962F-486B-9A5C-BEFA49183FF1}" type="datetimeFigureOut">
               <a:rPr lang="sv-FI" smtClean="0"/>
-              <a:t>13-05-2022</a:t>
+              <a:t>2024-01-26</a:t>
             </a:fld>
             <a:endParaRPr lang="sv-FI"/>
           </a:p>
@@ -1415,7 +1415,7 @@
           <a:p>
             <a:fld id="{1FA95016-962F-486B-9A5C-BEFA49183FF1}" type="datetimeFigureOut">
               <a:rPr lang="sv-FI" smtClean="0"/>
-              <a:t>13-05-2022</a:t>
+              <a:t>2024-01-26</a:t>
             </a:fld>
             <a:endParaRPr lang="sv-FI"/>
           </a:p>
@@ -1830,7 +1830,7 @@
           <a:p>
             <a:fld id="{1FA95016-962F-486B-9A5C-BEFA49183FF1}" type="datetimeFigureOut">
               <a:rPr lang="sv-FI" smtClean="0"/>
-              <a:t>13-05-2022</a:t>
+              <a:t>2024-01-26</a:t>
             </a:fld>
             <a:endParaRPr lang="sv-FI"/>
           </a:p>
@@ -1972,7 +1972,7 @@
           <a:p>
             <a:fld id="{1FA95016-962F-486B-9A5C-BEFA49183FF1}" type="datetimeFigureOut">
               <a:rPr lang="sv-FI" smtClean="0"/>
-              <a:t>13-05-2022</a:t>
+              <a:t>2024-01-26</a:t>
             </a:fld>
             <a:endParaRPr lang="sv-FI"/>
           </a:p>
@@ -2085,7 +2085,7 @@
           <a:p>
             <a:fld id="{1FA95016-962F-486B-9A5C-BEFA49183FF1}" type="datetimeFigureOut">
               <a:rPr lang="sv-FI" smtClean="0"/>
-              <a:t>13-05-2022</a:t>
+              <a:t>2024-01-26</a:t>
             </a:fld>
             <a:endParaRPr lang="sv-FI"/>
           </a:p>
@@ -2398,7 +2398,7 @@
           <a:p>
             <a:fld id="{1FA95016-962F-486B-9A5C-BEFA49183FF1}" type="datetimeFigureOut">
               <a:rPr lang="sv-FI" smtClean="0"/>
-              <a:t>13-05-2022</a:t>
+              <a:t>2024-01-26</a:t>
             </a:fld>
             <a:endParaRPr lang="sv-FI"/>
           </a:p>
@@ -2687,7 +2687,7 @@
           <a:p>
             <a:fld id="{1FA95016-962F-486B-9A5C-BEFA49183FF1}" type="datetimeFigureOut">
               <a:rPr lang="sv-FI" smtClean="0"/>
-              <a:t>13-05-2022</a:t>
+              <a:t>2024-01-26</a:t>
             </a:fld>
             <a:endParaRPr lang="sv-FI"/>
           </a:p>
@@ -2930,7 +2930,7 @@
           <a:p>
             <a:fld id="{1FA95016-962F-486B-9A5C-BEFA49183FF1}" type="datetimeFigureOut">
               <a:rPr lang="sv-FI" smtClean="0"/>
-              <a:t>13-05-2022</a:t>
+              <a:t>2024-01-26</a:t>
             </a:fld>
             <a:endParaRPr lang="sv-FI"/>
           </a:p>
@@ -4322,6 +4322,309 @@
           </a:prstGeom>
         </p:spPr>
       </p:pic>
+      <p:pic>
+        <p:nvPicPr>
+          <p:cNvPr id="10" name="Bildobjekt 6">
+            <a:extLst>
+              <a:ext uri="{FF2B5EF4-FFF2-40B4-BE49-F238E27FC236}">
+                <a16:creationId xmlns:a16="http://schemas.microsoft.com/office/drawing/2014/main" id="{ECF4F44F-8741-D180-3AB9-0D7C80799E07}"/>
+              </a:ext>
+            </a:extLst>
+          </p:cNvPr>
+          <p:cNvPicPr>
+            <a:picLocks noChangeAspect="1"/>
+          </p:cNvPicPr>
+          <p:nvPr/>
+        </p:nvPicPr>
+        <p:blipFill>
+          <a:blip r:embed="rId2"/>
+          <a:stretch>
+            <a:fillRect/>
+          </a:stretch>
+        </p:blipFill>
+        <p:spPr>
+          <a:xfrm>
+            <a:off x="5530726" y="3811844"/>
+            <a:ext cx="457200" cy="457200"/>
+          </a:xfrm>
+          <a:prstGeom prst="rect">
+            <a:avLst/>
+          </a:prstGeom>
+        </p:spPr>
+      </p:pic>
+      <p:pic>
+        <p:nvPicPr>
+          <p:cNvPr id="14" name="Bildobjekt 7">
+            <a:extLst>
+              <a:ext uri="{FF2B5EF4-FFF2-40B4-BE49-F238E27FC236}">
+                <a16:creationId xmlns:a16="http://schemas.microsoft.com/office/drawing/2014/main" id="{928FE7B1-9B4C-3CAB-D937-99F78AA64FB9}"/>
+              </a:ext>
+            </a:extLst>
+          </p:cNvPr>
+          <p:cNvPicPr>
+            <a:picLocks noChangeAspect="1"/>
+          </p:cNvPicPr>
+          <p:nvPr/>
+        </p:nvPicPr>
+        <p:blipFill rotWithShape="1">
+          <a:blip r:embed="rId2"/>
+          <a:srcRect l="55050" t="9092" r="9259" b="61952"/>
+          <a:stretch/>
+        </p:blipFill>
+        <p:spPr>
+          <a:xfrm>
+            <a:off x="5668214" y="3958086"/>
+            <a:ext cx="163176" cy="148552"/>
+          </a:xfrm>
+          <a:prstGeom prst="rect">
+            <a:avLst/>
+          </a:prstGeom>
+        </p:spPr>
+      </p:pic>
+      <p:pic>
+        <p:nvPicPr>
+          <p:cNvPr id="19" name="Bildobjekt 33">
+            <a:extLst>
+              <a:ext uri="{FF2B5EF4-FFF2-40B4-BE49-F238E27FC236}">
+                <a16:creationId xmlns:a16="http://schemas.microsoft.com/office/drawing/2014/main" id="{24B572A2-9650-1D8A-5749-950774F81F49}"/>
+              </a:ext>
+            </a:extLst>
+          </p:cNvPr>
+          <p:cNvPicPr>
+            <a:picLocks noChangeAspect="1"/>
+          </p:cNvPicPr>
+          <p:nvPr/>
+        </p:nvPicPr>
+        <p:blipFill>
+          <a:blip r:embed="rId3">
+            <a:extLst>
+              <a:ext uri="{28A0092B-C50C-407E-A947-70E740481C1C}">
+                <a14:useLocalDpi xmlns:a14="http://schemas.microsoft.com/office/drawing/2010/main" val="0"/>
+              </a:ext>
+            </a:extLst>
+          </a:blip>
+          <a:stretch>
+            <a:fillRect/>
+          </a:stretch>
+        </p:blipFill>
+        <p:spPr>
+          <a:xfrm>
+            <a:off x="5559307" y="3817263"/>
+            <a:ext cx="306620" cy="306620"/>
+          </a:xfrm>
+          <a:prstGeom prst="rect">
+            <a:avLst/>
+          </a:prstGeom>
+        </p:spPr>
+      </p:pic>
+      <p:sp>
+        <p:nvSpPr>
+          <p:cNvPr id="27" name="Rectangle 26">
+            <a:extLst>
+              <a:ext uri="{FF2B5EF4-FFF2-40B4-BE49-F238E27FC236}">
+                <a16:creationId xmlns:a16="http://schemas.microsoft.com/office/drawing/2014/main" id="{62318DD1-4800-1B59-8CDB-FED5D56345E0}"/>
+              </a:ext>
+            </a:extLst>
+          </p:cNvPr>
+          <p:cNvSpPr/>
+          <p:nvPr/>
+        </p:nvSpPr>
+        <p:spPr>
+          <a:xfrm>
+            <a:off x="5687217" y="4113578"/>
+            <a:ext cx="108000" cy="28800"/>
+          </a:xfrm>
+          <a:prstGeom prst="rect">
+            <a:avLst/>
+          </a:prstGeom>
+          <a:solidFill>
+            <a:schemeClr val="bg1"/>
+          </a:solidFill>
+          <a:ln>
+            <a:noFill/>
+          </a:ln>
+        </p:spPr>
+        <p:style>
+          <a:lnRef idx="2">
+            <a:schemeClr val="accent1">
+              <a:shade val="15000"/>
+            </a:schemeClr>
+          </a:lnRef>
+          <a:fillRef idx="1">
+            <a:schemeClr val="accent1"/>
+          </a:fillRef>
+          <a:effectRef idx="0">
+            <a:schemeClr val="accent1"/>
+          </a:effectRef>
+          <a:fontRef idx="minor">
+            <a:schemeClr val="lt1"/>
+          </a:fontRef>
+        </p:style>
+        <p:txBody>
+          <a:bodyPr rtlCol="0" anchor="ctr"/>
+          <a:lstStyle/>
+          <a:p>
+            <a:pPr algn="ctr"/>
+            <a:endParaRPr lang="en-FI"/>
+          </a:p>
+        </p:txBody>
+      </p:sp>
+      <p:sp>
+        <p:nvSpPr>
+          <p:cNvPr id="30" name="Rectangle 29">
+            <a:extLst>
+              <a:ext uri="{FF2B5EF4-FFF2-40B4-BE49-F238E27FC236}">
+                <a16:creationId xmlns:a16="http://schemas.microsoft.com/office/drawing/2014/main" id="{BB059C22-91C8-AAE0-36AC-57237AEE4750}"/>
+              </a:ext>
+            </a:extLst>
+          </p:cNvPr>
+          <p:cNvSpPr/>
+          <p:nvPr/>
+        </p:nvSpPr>
+        <p:spPr>
+          <a:xfrm>
+            <a:off x="5726507" y="4073978"/>
+            <a:ext cx="28800" cy="108000"/>
+          </a:xfrm>
+          <a:prstGeom prst="rect">
+            <a:avLst/>
+          </a:prstGeom>
+          <a:solidFill>
+            <a:schemeClr val="bg1"/>
+          </a:solidFill>
+          <a:ln>
+            <a:noFill/>
+          </a:ln>
+        </p:spPr>
+        <p:style>
+          <a:lnRef idx="2">
+            <a:schemeClr val="accent1">
+              <a:shade val="15000"/>
+            </a:schemeClr>
+          </a:lnRef>
+          <a:fillRef idx="1">
+            <a:schemeClr val="accent1"/>
+          </a:fillRef>
+          <a:effectRef idx="0">
+            <a:schemeClr val="accent1"/>
+          </a:effectRef>
+          <a:fontRef idx="minor">
+            <a:schemeClr val="lt1"/>
+          </a:fontRef>
+        </p:style>
+        <p:txBody>
+          <a:bodyPr rtlCol="0" anchor="ctr"/>
+          <a:lstStyle/>
+          <a:p>
+            <a:pPr algn="ctr"/>
+            <a:endParaRPr lang="en-FI"/>
+          </a:p>
+        </p:txBody>
+      </p:sp>
+      <p:sp>
+        <p:nvSpPr>
+          <p:cNvPr id="37" name="Rectangle 36">
+            <a:extLst>
+              <a:ext uri="{FF2B5EF4-FFF2-40B4-BE49-F238E27FC236}">
+                <a16:creationId xmlns:a16="http://schemas.microsoft.com/office/drawing/2014/main" id="{DB2CB243-3265-590B-67E7-AF3521067860}"/>
+              </a:ext>
+            </a:extLst>
+          </p:cNvPr>
+          <p:cNvSpPr/>
+          <p:nvPr/>
+        </p:nvSpPr>
+        <p:spPr>
+          <a:xfrm>
+            <a:off x="5814636" y="4113578"/>
+            <a:ext cx="108000" cy="28800"/>
+          </a:xfrm>
+          <a:prstGeom prst="rect">
+            <a:avLst/>
+          </a:prstGeom>
+          <a:solidFill>
+            <a:schemeClr val="bg1"/>
+          </a:solidFill>
+          <a:ln>
+            <a:noFill/>
+          </a:ln>
+        </p:spPr>
+        <p:style>
+          <a:lnRef idx="2">
+            <a:schemeClr val="accent1">
+              <a:shade val="15000"/>
+            </a:schemeClr>
+          </a:lnRef>
+          <a:fillRef idx="1">
+            <a:schemeClr val="accent1"/>
+          </a:fillRef>
+          <a:effectRef idx="0">
+            <a:schemeClr val="accent1"/>
+          </a:effectRef>
+          <a:fontRef idx="minor">
+            <a:schemeClr val="lt1"/>
+          </a:fontRef>
+        </p:style>
+        <p:txBody>
+          <a:bodyPr rtlCol="0" anchor="ctr"/>
+          <a:lstStyle/>
+          <a:p>
+            <a:pPr algn="ctr"/>
+            <a:endParaRPr lang="en-FI"/>
+          </a:p>
+        </p:txBody>
+      </p:sp>
+      <p:sp>
+        <p:nvSpPr>
+          <p:cNvPr id="39" name="Rectangle 38">
+            <a:extLst>
+              <a:ext uri="{FF2B5EF4-FFF2-40B4-BE49-F238E27FC236}">
+                <a16:creationId xmlns:a16="http://schemas.microsoft.com/office/drawing/2014/main" id="{7BCDB199-AE82-87B8-2A3C-6D31FBEAF5B2}"/>
+              </a:ext>
+            </a:extLst>
+          </p:cNvPr>
+          <p:cNvSpPr/>
+          <p:nvPr/>
+        </p:nvSpPr>
+        <p:spPr>
+          <a:xfrm>
+            <a:off x="5853206" y="4073978"/>
+            <a:ext cx="28800" cy="108000"/>
+          </a:xfrm>
+          <a:prstGeom prst="rect">
+            <a:avLst/>
+          </a:prstGeom>
+          <a:solidFill>
+            <a:schemeClr val="bg1"/>
+          </a:solidFill>
+          <a:ln>
+            <a:noFill/>
+          </a:ln>
+        </p:spPr>
+        <p:style>
+          <a:lnRef idx="2">
+            <a:schemeClr val="accent1">
+              <a:shade val="15000"/>
+            </a:schemeClr>
+          </a:lnRef>
+          <a:fillRef idx="1">
+            <a:schemeClr val="accent1"/>
+          </a:fillRef>
+          <a:effectRef idx="0">
+            <a:schemeClr val="accent1"/>
+          </a:effectRef>
+          <a:fontRef idx="minor">
+            <a:schemeClr val="lt1"/>
+          </a:fontRef>
+        </p:style>
+        <p:txBody>
+          <a:bodyPr rtlCol="0" anchor="ctr"/>
+          <a:lstStyle/>
+          <a:p>
+            <a:pPr algn="ctr"/>
+            <a:endParaRPr lang="en-FI"/>
+          </a:p>
+        </p:txBody>
+      </p:sp>
     </p:spTree>
     <p:extLst>
       <p:ext uri="{BB962C8B-B14F-4D97-AF65-F5344CB8AC3E}">

</xml_diff>

<commit_message>
Deployed d7e0f247 with MkDocs version: 1.2.3
</commit_message>
<xml_diff>
--- a/Style/Icon Graphics.pptx
+++ b/Style/Icon Graphics.pptx
@@ -261,7 +261,7 @@
           <a:p>
             <a:fld id="{1FA95016-962F-486B-9A5C-BEFA49183FF1}" type="datetimeFigureOut">
               <a:rPr lang="sv-FI" smtClean="0"/>
-              <a:t>2024-01-29</a:t>
+              <a:t>2024-10-13</a:t>
             </a:fld>
             <a:endParaRPr lang="sv-FI"/>
           </a:p>
@@ -461,7 +461,7 @@
           <a:p>
             <a:fld id="{1FA95016-962F-486B-9A5C-BEFA49183FF1}" type="datetimeFigureOut">
               <a:rPr lang="sv-FI" smtClean="0"/>
-              <a:t>2024-01-29</a:t>
+              <a:t>2024-10-13</a:t>
             </a:fld>
             <a:endParaRPr lang="sv-FI"/>
           </a:p>
@@ -671,7 +671,7 @@
           <a:p>
             <a:fld id="{1FA95016-962F-486B-9A5C-BEFA49183FF1}" type="datetimeFigureOut">
               <a:rPr lang="sv-FI" smtClean="0"/>
-              <a:t>2024-01-29</a:t>
+              <a:t>2024-10-13</a:t>
             </a:fld>
             <a:endParaRPr lang="sv-FI"/>
           </a:p>
@@ -871,7 +871,7 @@
           <a:p>
             <a:fld id="{1FA95016-962F-486B-9A5C-BEFA49183FF1}" type="datetimeFigureOut">
               <a:rPr lang="sv-FI" smtClean="0"/>
-              <a:t>2024-01-29</a:t>
+              <a:t>2024-10-13</a:t>
             </a:fld>
             <a:endParaRPr lang="sv-FI"/>
           </a:p>
@@ -1147,7 +1147,7 @@
           <a:p>
             <a:fld id="{1FA95016-962F-486B-9A5C-BEFA49183FF1}" type="datetimeFigureOut">
               <a:rPr lang="sv-FI" smtClean="0"/>
-              <a:t>2024-01-29</a:t>
+              <a:t>2024-10-13</a:t>
             </a:fld>
             <a:endParaRPr lang="sv-FI"/>
           </a:p>
@@ -1415,7 +1415,7 @@
           <a:p>
             <a:fld id="{1FA95016-962F-486B-9A5C-BEFA49183FF1}" type="datetimeFigureOut">
               <a:rPr lang="sv-FI" smtClean="0"/>
-              <a:t>2024-01-29</a:t>
+              <a:t>2024-10-13</a:t>
             </a:fld>
             <a:endParaRPr lang="sv-FI"/>
           </a:p>
@@ -1830,7 +1830,7 @@
           <a:p>
             <a:fld id="{1FA95016-962F-486B-9A5C-BEFA49183FF1}" type="datetimeFigureOut">
               <a:rPr lang="sv-FI" smtClean="0"/>
-              <a:t>2024-01-29</a:t>
+              <a:t>2024-10-13</a:t>
             </a:fld>
             <a:endParaRPr lang="sv-FI"/>
           </a:p>
@@ -1972,7 +1972,7 @@
           <a:p>
             <a:fld id="{1FA95016-962F-486B-9A5C-BEFA49183FF1}" type="datetimeFigureOut">
               <a:rPr lang="sv-FI" smtClean="0"/>
-              <a:t>2024-01-29</a:t>
+              <a:t>2024-10-13</a:t>
             </a:fld>
             <a:endParaRPr lang="sv-FI"/>
           </a:p>
@@ -2085,7 +2085,7 @@
           <a:p>
             <a:fld id="{1FA95016-962F-486B-9A5C-BEFA49183FF1}" type="datetimeFigureOut">
               <a:rPr lang="sv-FI" smtClean="0"/>
-              <a:t>2024-01-29</a:t>
+              <a:t>2024-10-13</a:t>
             </a:fld>
             <a:endParaRPr lang="sv-FI"/>
           </a:p>
@@ -2398,7 +2398,7 @@
           <a:p>
             <a:fld id="{1FA95016-962F-486B-9A5C-BEFA49183FF1}" type="datetimeFigureOut">
               <a:rPr lang="sv-FI" smtClean="0"/>
-              <a:t>2024-01-29</a:t>
+              <a:t>2024-10-13</a:t>
             </a:fld>
             <a:endParaRPr lang="sv-FI"/>
           </a:p>
@@ -2687,7 +2687,7 @@
           <a:p>
             <a:fld id="{1FA95016-962F-486B-9A5C-BEFA49183FF1}" type="datetimeFigureOut">
               <a:rPr lang="sv-FI" smtClean="0"/>
-              <a:t>2024-01-29</a:t>
+              <a:t>2024-10-13</a:t>
             </a:fld>
             <a:endParaRPr lang="sv-FI"/>
           </a:p>
@@ -2930,7 +2930,7 @@
           <a:p>
             <a:fld id="{1FA95016-962F-486B-9A5C-BEFA49183FF1}" type="datetimeFigureOut">
               <a:rPr lang="sv-FI" smtClean="0"/>
-              <a:t>2024-01-29</a:t>
+              <a:t>2024-10-13</a:t>
             </a:fld>
             <a:endParaRPr lang="sv-FI"/>
           </a:p>
@@ -4767,6 +4767,148 @@
           </a:p>
         </p:txBody>
       </p:sp>
+      <p:pic>
+        <p:nvPicPr>
+          <p:cNvPr id="23" name="Bildobjekt 6">
+            <a:extLst>
+              <a:ext uri="{FF2B5EF4-FFF2-40B4-BE49-F238E27FC236}">
+                <a16:creationId xmlns:a16="http://schemas.microsoft.com/office/drawing/2014/main" id="{AE4F894A-9920-1C1B-BDCC-A86E2178C6B3}"/>
+              </a:ext>
+            </a:extLst>
+          </p:cNvPr>
+          <p:cNvPicPr>
+            <a:picLocks noChangeAspect="1"/>
+          </p:cNvPicPr>
+          <p:nvPr/>
+        </p:nvPicPr>
+        <p:blipFill>
+          <a:blip r:embed="rId2"/>
+          <a:stretch>
+            <a:fillRect/>
+          </a:stretch>
+        </p:blipFill>
+        <p:spPr>
+          <a:xfrm>
+            <a:off x="3570899" y="4701297"/>
+            <a:ext cx="457200" cy="457200"/>
+          </a:xfrm>
+          <a:prstGeom prst="rect">
+            <a:avLst/>
+          </a:prstGeom>
+        </p:spPr>
+      </p:pic>
+      <p:pic>
+        <p:nvPicPr>
+          <p:cNvPr id="25" name="Bildobjekt 7">
+            <a:extLst>
+              <a:ext uri="{FF2B5EF4-FFF2-40B4-BE49-F238E27FC236}">
+                <a16:creationId xmlns:a16="http://schemas.microsoft.com/office/drawing/2014/main" id="{D0FA079F-083A-D878-78D4-B2B73035F520}"/>
+              </a:ext>
+            </a:extLst>
+          </p:cNvPr>
+          <p:cNvPicPr>
+            <a:picLocks noChangeAspect="1"/>
+          </p:cNvPicPr>
+          <p:nvPr/>
+        </p:nvPicPr>
+        <p:blipFill rotWithShape="1">
+          <a:blip r:embed="rId2"/>
+          <a:srcRect l="55050" t="9092" r="9259" b="61952"/>
+          <a:stretch/>
+        </p:blipFill>
+        <p:spPr>
+          <a:xfrm>
+            <a:off x="3717911" y="4847539"/>
+            <a:ext cx="163176" cy="148552"/>
+          </a:xfrm>
+          <a:prstGeom prst="rect">
+            <a:avLst/>
+          </a:prstGeom>
+        </p:spPr>
+      </p:pic>
+      <p:pic>
+        <p:nvPicPr>
+          <p:cNvPr id="32" name="Bildobjekt 33">
+            <a:extLst>
+              <a:ext uri="{FF2B5EF4-FFF2-40B4-BE49-F238E27FC236}">
+                <a16:creationId xmlns:a16="http://schemas.microsoft.com/office/drawing/2014/main" id="{789D0764-4FF9-A074-72AA-57D4D94FE309}"/>
+              </a:ext>
+            </a:extLst>
+          </p:cNvPr>
+          <p:cNvPicPr>
+            <a:picLocks noChangeAspect="1"/>
+          </p:cNvPicPr>
+          <p:nvPr/>
+        </p:nvPicPr>
+        <p:blipFill>
+          <a:blip r:embed="rId3">
+            <a:extLst>
+              <a:ext uri="{28A0092B-C50C-407E-A947-70E740481C1C}">
+                <a14:useLocalDpi xmlns:a14="http://schemas.microsoft.com/office/drawing/2010/main" val="0"/>
+              </a:ext>
+            </a:extLst>
+          </a:blip>
+          <a:stretch>
+            <a:fillRect/>
+          </a:stretch>
+        </p:blipFill>
+        <p:spPr>
+          <a:xfrm>
+            <a:off x="3599478" y="4716238"/>
+            <a:ext cx="306620" cy="306620"/>
+          </a:xfrm>
+          <a:prstGeom prst="rect">
+            <a:avLst/>
+          </a:prstGeom>
+        </p:spPr>
+      </p:pic>
+      <p:sp>
+        <p:nvSpPr>
+          <p:cNvPr id="40" name="TextBox 39">
+            <a:extLst>
+              <a:ext uri="{FF2B5EF4-FFF2-40B4-BE49-F238E27FC236}">
+                <a16:creationId xmlns:a16="http://schemas.microsoft.com/office/drawing/2014/main" id="{1F855B4A-56F1-C75C-15C6-1069718E7706}"/>
+              </a:ext>
+            </a:extLst>
+          </p:cNvPr>
+          <p:cNvSpPr txBox="1"/>
+          <p:nvPr/>
+        </p:nvSpPr>
+        <p:spPr>
+          <a:xfrm>
+            <a:off x="3636027" y="4945914"/>
+            <a:ext cx="326943" cy="153888"/>
+          </a:xfrm>
+          <a:prstGeom prst="rect">
+            <a:avLst/>
+          </a:prstGeom>
+          <a:noFill/>
+        </p:spPr>
+        <p:txBody>
+          <a:bodyPr wrap="square" lIns="0" tIns="0" rIns="0" bIns="0" rtlCol="0">
+            <a:spAutoFit/>
+          </a:bodyPr>
+          <a:lstStyle/>
+          <a:p>
+            <a:pPr algn="r"/>
+            <a:r>
+              <a:rPr lang="en-US" sz="1000" b="1" dirty="0">
+                <a:solidFill>
+                  <a:schemeClr val="bg1"/>
+                </a:solidFill>
+                <a:latin typeface="Consolas" panose="020B0609020204030204" pitchFamily="49" charset="0"/>
+              </a:rPr>
+              <a:t>API</a:t>
+            </a:r>
+            <a:endParaRPr lang="en-FI" sz="800" b="1" dirty="0">
+              <a:solidFill>
+                <a:schemeClr val="bg1"/>
+              </a:solidFill>
+              <a:latin typeface="Consolas" panose="020B0609020204030204" pitchFamily="49" charset="0"/>
+            </a:endParaRPr>
+          </a:p>
+        </p:txBody>
+      </p:sp>
     </p:spTree>
     <p:extLst>
       <p:ext uri="{BB962C8B-B14F-4D97-AF65-F5344CB8AC3E}">

</xml_diff>